<commit_message>
chore(claude): add code-reviewer agent and /review-code
- add a read-only code-reviewer subagent that reports by severity
- add a /review-code skill that runs it and shows its report
- allow read-only git commands and remove a one-off permission rule
- update the course notes in notes.pptx
- lets the reviewer check changes without edits or approval prompts
</commit_message>
<xml_diff>
--- a/notes.pptx
+++ b/notes.pptx
@@ -5,12 +5,17 @@
     <p:sldMasterId id="2147483648" r:id="rId1"/>
   </p:sldMasterIdLst>
   <p:notesMasterIdLst>
-    <p:notesMasterId r:id="rId5"/>
+    <p:notesMasterId r:id="rId10"/>
   </p:notesMasterIdLst>
   <p:sldIdLst>
     <p:sldId id="256" r:id="rId2"/>
     <p:sldId id="257" r:id="rId3"/>
     <p:sldId id="258" r:id="rId4"/>
+    <p:sldId id="259" r:id="rId5"/>
+    <p:sldId id="260" r:id="rId6"/>
+    <p:sldId id="261" r:id="rId7"/>
+    <p:sldId id="262" r:id="rId8"/>
+    <p:sldId id="263" r:id="rId9"/>
   </p:sldIdLst>
   <p:sldSz cx="12192000" cy="6858000"/>
   <p:notesSz cx="6858000" cy="9144000"/>
@@ -659,6 +664,624 @@
     <p:extLst>
       <p:ext uri="{BB962C8B-B14F-4D97-AF65-F5344CB8AC3E}">
         <p14:creationId xmlns:p14="http://schemas.microsoft.com/office/powerpoint/2010/main" val="313971137"/>
+      </p:ext>
+    </p:extLst>
+  </p:cSld>
+  <p:clrMapOvr>
+    <a:masterClrMapping/>
+  </p:clrMapOvr>
+</p:notes>
+</file>
+
+<file path=ppt/notesSlides/notesSlide3.xml><?xml version="1.0" encoding="utf-8"?>
+<p:notes xmlns:a="http://schemas.openxmlformats.org/drawingml/2006/main" xmlns:r="http://schemas.openxmlformats.org/officeDocument/2006/relationships" xmlns:p="http://schemas.openxmlformats.org/presentationml/2006/main">
+  <p:cSld>
+    <p:spTree>
+      <p:nvGrpSpPr>
+        <p:cNvPr id="1" name="">
+          <a:extLst>
+            <a:ext uri="{FF2B5EF4-FFF2-40B4-BE49-F238E27FC236}">
+              <a16:creationId xmlns:a16="http://schemas.microsoft.com/office/drawing/2014/main" id="{16CBB2D8-6084-BFA6-1D3D-872BDE29572E}"/>
+            </a:ext>
+          </a:extLst>
+        </p:cNvPr>
+        <p:cNvGrpSpPr/>
+        <p:nvPr/>
+      </p:nvGrpSpPr>
+      <p:grpSpPr>
+        <a:xfrm>
+          <a:off x="0" y="0"/>
+          <a:ext cx="0" cy="0"/>
+          <a:chOff x="0" y="0"/>
+          <a:chExt cx="0" cy="0"/>
+        </a:xfrm>
+      </p:grpSpPr>
+      <p:sp>
+        <p:nvSpPr>
+          <p:cNvPr id="2" name="Slide Image Placeholder 1">
+            <a:extLst>
+              <a:ext uri="{FF2B5EF4-FFF2-40B4-BE49-F238E27FC236}">
+                <a16:creationId xmlns:a16="http://schemas.microsoft.com/office/drawing/2014/main" id="{14D9C7FE-5F67-E736-FE39-7A22370D7C30}"/>
+              </a:ext>
+            </a:extLst>
+          </p:cNvPr>
+          <p:cNvSpPr>
+            <a:spLocks noGrp="1" noRot="1" noChangeAspect="1"/>
+          </p:cNvSpPr>
+          <p:nvPr>
+            <p:ph type="sldImg"/>
+          </p:nvPr>
+        </p:nvSpPr>
+        <p:spPr/>
+      </p:sp>
+      <p:sp>
+        <p:nvSpPr>
+          <p:cNvPr id="3" name="Notes Placeholder 2">
+            <a:extLst>
+              <a:ext uri="{FF2B5EF4-FFF2-40B4-BE49-F238E27FC236}">
+                <a16:creationId xmlns:a16="http://schemas.microsoft.com/office/drawing/2014/main" id="{F44F887E-9439-1D94-D6B2-F8F6EE055409}"/>
+              </a:ext>
+            </a:extLst>
+          </p:cNvPr>
+          <p:cNvSpPr>
+            <a:spLocks noGrp="1"/>
+          </p:cNvSpPr>
+          <p:nvPr>
+            <p:ph type="body" idx="1"/>
+          </p:nvPr>
+        </p:nvSpPr>
+        <p:spPr/>
+        <p:txBody>
+          <a:bodyPr/>
+          <a:lstStyle/>
+          <a:p>
+            <a:r>
+              <a:rPr lang="de-DE" dirty="0"/>
+              <a:t>- For better structuring, breakdown instructions by topic or component, create specific .md file with detailed instructions respectively, and reference these files in the main .CLAUDE.md</a:t>
+            </a:r>
+          </a:p>
+        </p:txBody>
+      </p:sp>
+      <p:sp>
+        <p:nvSpPr>
+          <p:cNvPr id="4" name="Slide Number Placeholder 3">
+            <a:extLst>
+              <a:ext uri="{FF2B5EF4-FFF2-40B4-BE49-F238E27FC236}">
+                <a16:creationId xmlns:a16="http://schemas.microsoft.com/office/drawing/2014/main" id="{A947D8BD-7928-612F-9C65-30371D4A913C}"/>
+              </a:ext>
+            </a:extLst>
+          </p:cNvPr>
+          <p:cNvSpPr>
+            <a:spLocks noGrp="1"/>
+          </p:cNvSpPr>
+          <p:nvPr>
+            <p:ph type="sldNum" sz="quarter" idx="5"/>
+          </p:nvPr>
+        </p:nvSpPr>
+        <p:spPr/>
+        <p:txBody>
+          <a:bodyPr/>
+          <a:lstStyle/>
+          <a:p>
+            <a:fld id="{3AD89447-99D4-455B-AC7D-81B0F0BC37B7}" type="slidenum">
+              <a:rPr lang="de-DE" smtClean="0"/>
+              <a:t>4</a:t>
+            </a:fld>
+            <a:endParaRPr lang="de-DE"/>
+          </a:p>
+        </p:txBody>
+      </p:sp>
+    </p:spTree>
+    <p:extLst>
+      <p:ext uri="{BB962C8B-B14F-4D97-AF65-F5344CB8AC3E}">
+        <p14:creationId xmlns:p14="http://schemas.microsoft.com/office/powerpoint/2010/main" val="2063489802"/>
+      </p:ext>
+    </p:extLst>
+  </p:cSld>
+  <p:clrMapOvr>
+    <a:masterClrMapping/>
+  </p:clrMapOvr>
+</p:notes>
+</file>
+
+<file path=ppt/notesSlides/notesSlide4.xml><?xml version="1.0" encoding="utf-8"?>
+<p:notes xmlns:a="http://schemas.openxmlformats.org/drawingml/2006/main" xmlns:r="http://schemas.openxmlformats.org/officeDocument/2006/relationships" xmlns:p="http://schemas.openxmlformats.org/presentationml/2006/main">
+  <p:cSld>
+    <p:spTree>
+      <p:nvGrpSpPr>
+        <p:cNvPr id="1" name="">
+          <a:extLst>
+            <a:ext uri="{FF2B5EF4-FFF2-40B4-BE49-F238E27FC236}">
+              <a16:creationId xmlns:a16="http://schemas.microsoft.com/office/drawing/2014/main" id="{4C359C2B-F996-92EC-89D7-8787BEFDCC5C}"/>
+            </a:ext>
+          </a:extLst>
+        </p:cNvPr>
+        <p:cNvGrpSpPr/>
+        <p:nvPr/>
+      </p:nvGrpSpPr>
+      <p:grpSpPr>
+        <a:xfrm>
+          <a:off x="0" y="0"/>
+          <a:ext cx="0" cy="0"/>
+          <a:chOff x="0" y="0"/>
+          <a:chExt cx="0" cy="0"/>
+        </a:xfrm>
+      </p:grpSpPr>
+      <p:sp>
+        <p:nvSpPr>
+          <p:cNvPr id="2" name="Slide Image Placeholder 1">
+            <a:extLst>
+              <a:ext uri="{FF2B5EF4-FFF2-40B4-BE49-F238E27FC236}">
+                <a16:creationId xmlns:a16="http://schemas.microsoft.com/office/drawing/2014/main" id="{50467F08-7D13-31F3-EA36-DDE5D0D43388}"/>
+              </a:ext>
+            </a:extLst>
+          </p:cNvPr>
+          <p:cNvSpPr>
+            <a:spLocks noGrp="1" noRot="1" noChangeAspect="1"/>
+          </p:cNvSpPr>
+          <p:nvPr>
+            <p:ph type="sldImg"/>
+          </p:nvPr>
+        </p:nvSpPr>
+        <p:spPr/>
+      </p:sp>
+      <p:sp>
+        <p:nvSpPr>
+          <p:cNvPr id="3" name="Notes Placeholder 2">
+            <a:extLst>
+              <a:ext uri="{FF2B5EF4-FFF2-40B4-BE49-F238E27FC236}">
+                <a16:creationId xmlns:a16="http://schemas.microsoft.com/office/drawing/2014/main" id="{C3B77EDB-6E87-0545-D83E-5D9763672E1A}"/>
+              </a:ext>
+            </a:extLst>
+          </p:cNvPr>
+          <p:cNvSpPr>
+            <a:spLocks noGrp="1"/>
+          </p:cNvSpPr>
+          <p:nvPr>
+            <p:ph type="body" idx="1"/>
+          </p:nvPr>
+        </p:nvSpPr>
+        <p:spPr/>
+        <p:txBody>
+          <a:bodyPr/>
+          <a:lstStyle/>
+          <a:p>
+            <a:r>
+              <a:rPr lang="de-DE" dirty="0"/>
+              <a:t>Brad‘s common MCPS:</a:t>
+            </a:r>
+          </a:p>
+          <a:p>
+            <a:pPr marL="171450" indent="-171450">
+              <a:buFontTx/>
+              <a:buChar char="-"/>
+            </a:pPr>
+            <a:r>
+              <a:rPr lang="de-DE" dirty="0"/>
+              <a:t>Context7</a:t>
+            </a:r>
+          </a:p>
+          <a:p>
+            <a:pPr marL="171450" indent="-171450">
+              <a:buFontTx/>
+              <a:buChar char="-"/>
+            </a:pPr>
+            <a:r>
+              <a:rPr lang="de-DE" dirty="0"/>
+              <a:t>Neon</a:t>
+            </a:r>
+          </a:p>
+          <a:p>
+            <a:pPr marL="171450" indent="-171450">
+              <a:buFontTx/>
+              <a:buChar char="-"/>
+            </a:pPr>
+            <a:r>
+              <a:rPr lang="de-DE" dirty="0"/>
+              <a:t>Playwright</a:t>
+            </a:r>
+          </a:p>
+        </p:txBody>
+      </p:sp>
+      <p:sp>
+        <p:nvSpPr>
+          <p:cNvPr id="4" name="Slide Number Placeholder 3">
+            <a:extLst>
+              <a:ext uri="{FF2B5EF4-FFF2-40B4-BE49-F238E27FC236}">
+                <a16:creationId xmlns:a16="http://schemas.microsoft.com/office/drawing/2014/main" id="{7BD9AC08-F06F-3B42-A4D2-B98B8C5AB6B9}"/>
+              </a:ext>
+            </a:extLst>
+          </p:cNvPr>
+          <p:cNvSpPr>
+            <a:spLocks noGrp="1"/>
+          </p:cNvSpPr>
+          <p:nvPr>
+            <p:ph type="sldNum" sz="quarter" idx="5"/>
+          </p:nvPr>
+        </p:nvSpPr>
+        <p:spPr/>
+        <p:txBody>
+          <a:bodyPr/>
+          <a:lstStyle/>
+          <a:p>
+            <a:fld id="{3AD89447-99D4-455B-AC7D-81B0F0BC37B7}" type="slidenum">
+              <a:rPr lang="de-DE" smtClean="0"/>
+              <a:t>5</a:t>
+            </a:fld>
+            <a:endParaRPr lang="de-DE"/>
+          </a:p>
+        </p:txBody>
+      </p:sp>
+    </p:spTree>
+    <p:extLst>
+      <p:ext uri="{BB962C8B-B14F-4D97-AF65-F5344CB8AC3E}">
+        <p14:creationId xmlns:p14="http://schemas.microsoft.com/office/powerpoint/2010/main" val="678246034"/>
+      </p:ext>
+    </p:extLst>
+  </p:cSld>
+  <p:clrMapOvr>
+    <a:masterClrMapping/>
+  </p:clrMapOvr>
+</p:notes>
+</file>
+
+<file path=ppt/notesSlides/notesSlide5.xml><?xml version="1.0" encoding="utf-8"?>
+<p:notes xmlns:a="http://schemas.openxmlformats.org/drawingml/2006/main" xmlns:r="http://schemas.openxmlformats.org/officeDocument/2006/relationships" xmlns:p="http://schemas.openxmlformats.org/presentationml/2006/main">
+  <p:cSld>
+    <p:spTree>
+      <p:nvGrpSpPr>
+        <p:cNvPr id="1" name="">
+          <a:extLst>
+            <a:ext uri="{FF2B5EF4-FFF2-40B4-BE49-F238E27FC236}">
+              <a16:creationId xmlns:a16="http://schemas.microsoft.com/office/drawing/2014/main" id="{48B0BC5E-F3C9-B300-A5CD-5E69BC6252D7}"/>
+            </a:ext>
+          </a:extLst>
+        </p:cNvPr>
+        <p:cNvGrpSpPr/>
+        <p:nvPr/>
+      </p:nvGrpSpPr>
+      <p:grpSpPr>
+        <a:xfrm>
+          <a:off x="0" y="0"/>
+          <a:ext cx="0" cy="0"/>
+          <a:chOff x="0" y="0"/>
+          <a:chExt cx="0" cy="0"/>
+        </a:xfrm>
+      </p:grpSpPr>
+      <p:sp>
+        <p:nvSpPr>
+          <p:cNvPr id="2" name="Slide Image Placeholder 1">
+            <a:extLst>
+              <a:ext uri="{FF2B5EF4-FFF2-40B4-BE49-F238E27FC236}">
+                <a16:creationId xmlns:a16="http://schemas.microsoft.com/office/drawing/2014/main" id="{6CC41F6C-CE0C-E8DA-440A-1A20C8B926D6}"/>
+              </a:ext>
+            </a:extLst>
+          </p:cNvPr>
+          <p:cNvSpPr>
+            <a:spLocks noGrp="1" noRot="1" noChangeAspect="1"/>
+          </p:cNvSpPr>
+          <p:nvPr>
+            <p:ph type="sldImg"/>
+          </p:nvPr>
+        </p:nvSpPr>
+        <p:spPr/>
+      </p:sp>
+      <p:sp>
+        <p:nvSpPr>
+          <p:cNvPr id="3" name="Notes Placeholder 2">
+            <a:extLst>
+              <a:ext uri="{FF2B5EF4-FFF2-40B4-BE49-F238E27FC236}">
+                <a16:creationId xmlns:a16="http://schemas.microsoft.com/office/drawing/2014/main" id="{D8CB2B63-9B97-BB3E-610E-6CBE8ED8014E}"/>
+              </a:ext>
+            </a:extLst>
+          </p:cNvPr>
+          <p:cNvSpPr>
+            <a:spLocks noGrp="1"/>
+          </p:cNvSpPr>
+          <p:nvPr>
+            <p:ph type="body" idx="1"/>
+          </p:nvPr>
+        </p:nvSpPr>
+        <p:spPr/>
+        <p:txBody>
+          <a:bodyPr/>
+          <a:lstStyle/>
+          <a:p>
+            <a:endParaRPr lang="de-DE" dirty="0"/>
+          </a:p>
+        </p:txBody>
+      </p:sp>
+      <p:sp>
+        <p:nvSpPr>
+          <p:cNvPr id="4" name="Slide Number Placeholder 3">
+            <a:extLst>
+              <a:ext uri="{FF2B5EF4-FFF2-40B4-BE49-F238E27FC236}">
+                <a16:creationId xmlns:a16="http://schemas.microsoft.com/office/drawing/2014/main" id="{B87A9B71-82EE-EAE7-2951-67DC3D7E4922}"/>
+              </a:ext>
+            </a:extLst>
+          </p:cNvPr>
+          <p:cNvSpPr>
+            <a:spLocks noGrp="1"/>
+          </p:cNvSpPr>
+          <p:nvPr>
+            <p:ph type="sldNum" sz="quarter" idx="5"/>
+          </p:nvPr>
+        </p:nvSpPr>
+        <p:spPr/>
+        <p:txBody>
+          <a:bodyPr/>
+          <a:lstStyle/>
+          <a:p>
+            <a:fld id="{3AD89447-99D4-455B-AC7D-81B0F0BC37B7}" type="slidenum">
+              <a:rPr lang="de-DE" smtClean="0"/>
+              <a:t>6</a:t>
+            </a:fld>
+            <a:endParaRPr lang="de-DE"/>
+          </a:p>
+        </p:txBody>
+      </p:sp>
+    </p:spTree>
+    <p:extLst>
+      <p:ext uri="{BB962C8B-B14F-4D97-AF65-F5344CB8AC3E}">
+        <p14:creationId xmlns:p14="http://schemas.microsoft.com/office/powerpoint/2010/main" val="3415583603"/>
+      </p:ext>
+    </p:extLst>
+  </p:cSld>
+  <p:clrMapOvr>
+    <a:masterClrMapping/>
+  </p:clrMapOvr>
+</p:notes>
+</file>
+
+<file path=ppt/notesSlides/notesSlide6.xml><?xml version="1.0" encoding="utf-8"?>
+<p:notes xmlns:a="http://schemas.openxmlformats.org/drawingml/2006/main" xmlns:r="http://schemas.openxmlformats.org/officeDocument/2006/relationships" xmlns:p="http://schemas.openxmlformats.org/presentationml/2006/main">
+  <p:cSld>
+    <p:spTree>
+      <p:nvGrpSpPr>
+        <p:cNvPr id="1" name="">
+          <a:extLst>
+            <a:ext uri="{FF2B5EF4-FFF2-40B4-BE49-F238E27FC236}">
+              <a16:creationId xmlns:a16="http://schemas.microsoft.com/office/drawing/2014/main" id="{5FFCE90A-AE16-CF23-2C46-50B9547DBCAB}"/>
+            </a:ext>
+          </a:extLst>
+        </p:cNvPr>
+        <p:cNvGrpSpPr/>
+        <p:nvPr/>
+      </p:nvGrpSpPr>
+      <p:grpSpPr>
+        <a:xfrm>
+          <a:off x="0" y="0"/>
+          <a:ext cx="0" cy="0"/>
+          <a:chOff x="0" y="0"/>
+          <a:chExt cx="0" cy="0"/>
+        </a:xfrm>
+      </p:grpSpPr>
+      <p:sp>
+        <p:nvSpPr>
+          <p:cNvPr id="2" name="Slide Image Placeholder 1">
+            <a:extLst>
+              <a:ext uri="{FF2B5EF4-FFF2-40B4-BE49-F238E27FC236}">
+                <a16:creationId xmlns:a16="http://schemas.microsoft.com/office/drawing/2014/main" id="{719E212A-776C-DDE1-D55C-6C15A96B3352}"/>
+              </a:ext>
+            </a:extLst>
+          </p:cNvPr>
+          <p:cNvSpPr>
+            <a:spLocks noGrp="1" noRot="1" noChangeAspect="1"/>
+          </p:cNvSpPr>
+          <p:nvPr>
+            <p:ph type="sldImg"/>
+          </p:nvPr>
+        </p:nvSpPr>
+        <p:spPr/>
+      </p:sp>
+      <p:sp>
+        <p:nvSpPr>
+          <p:cNvPr id="3" name="Notes Placeholder 2">
+            <a:extLst>
+              <a:ext uri="{FF2B5EF4-FFF2-40B4-BE49-F238E27FC236}">
+                <a16:creationId xmlns:a16="http://schemas.microsoft.com/office/drawing/2014/main" id="{92FDDED5-41DC-AA66-6C9A-F24DF32D0A3D}"/>
+              </a:ext>
+            </a:extLst>
+          </p:cNvPr>
+          <p:cNvSpPr>
+            <a:spLocks noGrp="1"/>
+          </p:cNvSpPr>
+          <p:nvPr>
+            <p:ph type="body" idx="1"/>
+          </p:nvPr>
+        </p:nvSpPr>
+        <p:spPr/>
+        <p:txBody>
+          <a:bodyPr/>
+          <a:lstStyle/>
+          <a:p>
+            <a:pPr marL="171450" indent="-171450">
+              <a:buFontTx/>
+              <a:buChar char="-"/>
+            </a:pPr>
+            <a:r>
+              <a:rPr lang="de-DE" dirty="0"/>
+              <a:t>Basically a seperate claude session to handle a specific task</a:t>
+            </a:r>
+          </a:p>
+          <a:p>
+            <a:pPr marL="171450" indent="-171450">
+              <a:buFontTx/>
+              <a:buChar char="-"/>
+            </a:pPr>
+            <a:r>
+              <a:rPr lang="de-DE" dirty="0"/>
+              <a:t>Has own context window</a:t>
+            </a:r>
+          </a:p>
+          <a:p>
+            <a:pPr marL="171450" indent="-171450">
+              <a:buFontTx/>
+              <a:buChar char="-"/>
+            </a:pPr>
+            <a:r>
+              <a:rPr lang="de-DE" dirty="0"/>
+              <a:t>Example use cases: dead code, code to optimize</a:t>
+            </a:r>
+          </a:p>
+          <a:p>
+            <a:pPr marL="171450" indent="-171450">
+              <a:buFontTx/>
+              <a:buChar char="-"/>
+            </a:pPr>
+            <a:r>
+              <a:rPr lang="de-DE" dirty="0"/>
+              <a:t>Built-in for example: </a:t>
+            </a:r>
+            <a:r>
+              <a:rPr lang="de-DE"/>
+              <a:t>Explore Subagent</a:t>
+            </a:r>
+            <a:endParaRPr lang="de-DE" dirty="0"/>
+          </a:p>
+        </p:txBody>
+      </p:sp>
+      <p:sp>
+        <p:nvSpPr>
+          <p:cNvPr id="4" name="Slide Number Placeholder 3">
+            <a:extLst>
+              <a:ext uri="{FF2B5EF4-FFF2-40B4-BE49-F238E27FC236}">
+                <a16:creationId xmlns:a16="http://schemas.microsoft.com/office/drawing/2014/main" id="{B9918AA8-06A0-7FF0-9330-2BD068EDA08A}"/>
+              </a:ext>
+            </a:extLst>
+          </p:cNvPr>
+          <p:cNvSpPr>
+            <a:spLocks noGrp="1"/>
+          </p:cNvSpPr>
+          <p:nvPr>
+            <p:ph type="sldNum" sz="quarter" idx="5"/>
+          </p:nvPr>
+        </p:nvSpPr>
+        <p:spPr/>
+        <p:txBody>
+          <a:bodyPr/>
+          <a:lstStyle/>
+          <a:p>
+            <a:fld id="{3AD89447-99D4-455B-AC7D-81B0F0BC37B7}" type="slidenum">
+              <a:rPr lang="de-DE" smtClean="0"/>
+              <a:t>7</a:t>
+            </a:fld>
+            <a:endParaRPr lang="de-DE"/>
+          </a:p>
+        </p:txBody>
+      </p:sp>
+    </p:spTree>
+    <p:extLst>
+      <p:ext uri="{BB962C8B-B14F-4D97-AF65-F5344CB8AC3E}">
+        <p14:creationId xmlns:p14="http://schemas.microsoft.com/office/powerpoint/2010/main" val="1756435653"/>
+      </p:ext>
+    </p:extLst>
+  </p:cSld>
+  <p:clrMapOvr>
+    <a:masterClrMapping/>
+  </p:clrMapOvr>
+</p:notes>
+</file>
+
+<file path=ppt/notesSlides/notesSlide7.xml><?xml version="1.0" encoding="utf-8"?>
+<p:notes xmlns:a="http://schemas.openxmlformats.org/drawingml/2006/main" xmlns:r="http://schemas.openxmlformats.org/officeDocument/2006/relationships" xmlns:p="http://schemas.openxmlformats.org/presentationml/2006/main">
+  <p:cSld>
+    <p:spTree>
+      <p:nvGrpSpPr>
+        <p:cNvPr id="1" name="">
+          <a:extLst>
+            <a:ext uri="{FF2B5EF4-FFF2-40B4-BE49-F238E27FC236}">
+              <a16:creationId xmlns:a16="http://schemas.microsoft.com/office/drawing/2014/main" id="{07F976E5-F932-6287-9509-7679F1788D27}"/>
+            </a:ext>
+          </a:extLst>
+        </p:cNvPr>
+        <p:cNvGrpSpPr/>
+        <p:nvPr/>
+      </p:nvGrpSpPr>
+      <p:grpSpPr>
+        <a:xfrm>
+          <a:off x="0" y="0"/>
+          <a:ext cx="0" cy="0"/>
+          <a:chOff x="0" y="0"/>
+          <a:chExt cx="0" cy="0"/>
+        </a:xfrm>
+      </p:grpSpPr>
+      <p:sp>
+        <p:nvSpPr>
+          <p:cNvPr id="2" name="Slide Image Placeholder 1">
+            <a:extLst>
+              <a:ext uri="{FF2B5EF4-FFF2-40B4-BE49-F238E27FC236}">
+                <a16:creationId xmlns:a16="http://schemas.microsoft.com/office/drawing/2014/main" id="{3F7A5447-E2E7-EE77-443E-16A4D8A72245}"/>
+              </a:ext>
+            </a:extLst>
+          </p:cNvPr>
+          <p:cNvSpPr>
+            <a:spLocks noGrp="1" noRot="1" noChangeAspect="1"/>
+          </p:cNvSpPr>
+          <p:nvPr>
+            <p:ph type="sldImg"/>
+          </p:nvPr>
+        </p:nvSpPr>
+        <p:spPr/>
+      </p:sp>
+      <p:sp>
+        <p:nvSpPr>
+          <p:cNvPr id="3" name="Notes Placeholder 2">
+            <a:extLst>
+              <a:ext uri="{FF2B5EF4-FFF2-40B4-BE49-F238E27FC236}">
+                <a16:creationId xmlns:a16="http://schemas.microsoft.com/office/drawing/2014/main" id="{318BD1F8-2E1F-27B3-0CBD-7FB0EF42A4A0}"/>
+              </a:ext>
+            </a:extLst>
+          </p:cNvPr>
+          <p:cNvSpPr>
+            <a:spLocks noGrp="1"/>
+          </p:cNvSpPr>
+          <p:nvPr>
+            <p:ph type="body" idx="1"/>
+          </p:nvPr>
+        </p:nvSpPr>
+        <p:spPr/>
+        <p:txBody>
+          <a:bodyPr/>
+          <a:lstStyle/>
+          <a:p>
+            <a:endParaRPr lang="de-DE" dirty="0"/>
+          </a:p>
+        </p:txBody>
+      </p:sp>
+      <p:sp>
+        <p:nvSpPr>
+          <p:cNvPr id="4" name="Slide Number Placeholder 3">
+            <a:extLst>
+              <a:ext uri="{FF2B5EF4-FFF2-40B4-BE49-F238E27FC236}">
+                <a16:creationId xmlns:a16="http://schemas.microsoft.com/office/drawing/2014/main" id="{16ED0964-8D52-6020-66B0-7A5B33EB16E4}"/>
+              </a:ext>
+            </a:extLst>
+          </p:cNvPr>
+          <p:cNvSpPr>
+            <a:spLocks noGrp="1"/>
+          </p:cNvSpPr>
+          <p:nvPr>
+            <p:ph type="sldNum" sz="quarter" idx="5"/>
+          </p:nvPr>
+        </p:nvSpPr>
+        <p:spPr/>
+        <p:txBody>
+          <a:bodyPr/>
+          <a:lstStyle/>
+          <a:p>
+            <a:fld id="{3AD89447-99D4-455B-AC7D-81B0F0BC37B7}" type="slidenum">
+              <a:rPr lang="de-DE" smtClean="0"/>
+              <a:t>8</a:t>
+            </a:fld>
+            <a:endParaRPr lang="de-DE"/>
+          </a:p>
+        </p:txBody>
+      </p:sp>
+    </p:spTree>
+    <p:extLst>
+      <p:ext uri="{BB962C8B-B14F-4D97-AF65-F5344CB8AC3E}">
+        <p14:creationId xmlns:p14="http://schemas.microsoft.com/office/powerpoint/2010/main" val="2994822210"/>
       </p:ext>
     </p:extLst>
   </p:cSld>
@@ -4280,6 +4903,625 @@
     <p:extLst>
       <p:ext uri="{BB962C8B-B14F-4D97-AF65-F5344CB8AC3E}">
         <p14:creationId xmlns:p14="http://schemas.microsoft.com/office/powerpoint/2010/main" val="3152659794"/>
+      </p:ext>
+    </p:extLst>
+  </p:cSld>
+  <p:clrMapOvr>
+    <a:masterClrMapping/>
+  </p:clrMapOvr>
+</p:sld>
+</file>
+
+<file path=ppt/slides/slide4.xml><?xml version="1.0" encoding="utf-8"?>
+<p:sld xmlns:a="http://schemas.openxmlformats.org/drawingml/2006/main" xmlns:r="http://schemas.openxmlformats.org/officeDocument/2006/relationships" xmlns:p="http://schemas.openxmlformats.org/presentationml/2006/main">
+  <p:cSld>
+    <p:spTree>
+      <p:nvGrpSpPr>
+        <p:cNvPr id="1" name="">
+          <a:extLst>
+            <a:ext uri="{FF2B5EF4-FFF2-40B4-BE49-F238E27FC236}">
+              <a16:creationId xmlns:a16="http://schemas.microsoft.com/office/drawing/2014/main" id="{407E2C57-8801-5A64-D4EB-9242C9A79FDD}"/>
+            </a:ext>
+          </a:extLst>
+        </p:cNvPr>
+        <p:cNvGrpSpPr/>
+        <p:nvPr/>
+      </p:nvGrpSpPr>
+      <p:grpSpPr>
+        <a:xfrm>
+          <a:off x="0" y="0"/>
+          <a:ext cx="0" cy="0"/>
+          <a:chOff x="0" y="0"/>
+          <a:chExt cx="0" cy="0"/>
+        </a:xfrm>
+      </p:grpSpPr>
+      <p:pic>
+        <p:nvPicPr>
+          <p:cNvPr id="3" name="Picture 2">
+            <a:extLst>
+              <a:ext uri="{FF2B5EF4-FFF2-40B4-BE49-F238E27FC236}">
+                <a16:creationId xmlns:a16="http://schemas.microsoft.com/office/drawing/2014/main" id="{5BD05163-BBFE-FE69-B5CF-B1931C4E41E4}"/>
+              </a:ext>
+            </a:extLst>
+          </p:cNvPr>
+          <p:cNvPicPr>
+            <a:picLocks noChangeAspect="1"/>
+          </p:cNvPicPr>
+          <p:nvPr/>
+        </p:nvPicPr>
+        <p:blipFill>
+          <a:blip r:embed="rId3"/>
+          <a:stretch>
+            <a:fillRect/>
+          </a:stretch>
+        </p:blipFill>
+        <p:spPr>
+          <a:xfrm>
+            <a:off x="0" y="0"/>
+            <a:ext cx="12192000" cy="6858000"/>
+          </a:xfrm>
+          <a:prstGeom prst="rect">
+            <a:avLst/>
+          </a:prstGeom>
+        </p:spPr>
+      </p:pic>
+    </p:spTree>
+    <p:extLst>
+      <p:ext uri="{BB962C8B-B14F-4D97-AF65-F5344CB8AC3E}">
+        <p14:creationId xmlns:p14="http://schemas.microsoft.com/office/powerpoint/2010/main" val="2020580474"/>
+      </p:ext>
+    </p:extLst>
+  </p:cSld>
+  <p:clrMapOvr>
+    <a:masterClrMapping/>
+  </p:clrMapOvr>
+</p:sld>
+</file>
+
+<file path=ppt/slides/slide5.xml><?xml version="1.0" encoding="utf-8"?>
+<p:sld xmlns:a="http://schemas.openxmlformats.org/drawingml/2006/main" xmlns:r="http://schemas.openxmlformats.org/officeDocument/2006/relationships" xmlns:p="http://schemas.openxmlformats.org/presentationml/2006/main">
+  <p:cSld>
+    <p:spTree>
+      <p:nvGrpSpPr>
+        <p:cNvPr id="1" name="">
+          <a:extLst>
+            <a:ext uri="{FF2B5EF4-FFF2-40B4-BE49-F238E27FC236}">
+              <a16:creationId xmlns:a16="http://schemas.microsoft.com/office/drawing/2014/main" id="{1830C2C0-65B1-715B-5AF6-BAEFF2E34E67}"/>
+            </a:ext>
+          </a:extLst>
+        </p:cNvPr>
+        <p:cNvGrpSpPr/>
+        <p:nvPr/>
+      </p:nvGrpSpPr>
+      <p:grpSpPr>
+        <a:xfrm>
+          <a:off x="0" y="0"/>
+          <a:ext cx="0" cy="0"/>
+          <a:chOff x="0" y="0"/>
+          <a:chExt cx="0" cy="0"/>
+        </a:xfrm>
+      </p:grpSpPr>
+      <p:pic>
+        <p:nvPicPr>
+          <p:cNvPr id="4" name="Picture 3">
+            <a:extLst>
+              <a:ext uri="{FF2B5EF4-FFF2-40B4-BE49-F238E27FC236}">
+                <a16:creationId xmlns:a16="http://schemas.microsoft.com/office/drawing/2014/main" id="{D4FB8777-B6C6-B907-A3C6-174E50010CE5}"/>
+              </a:ext>
+            </a:extLst>
+          </p:cNvPr>
+          <p:cNvPicPr>
+            <a:picLocks noChangeAspect="1"/>
+          </p:cNvPicPr>
+          <p:nvPr/>
+        </p:nvPicPr>
+        <p:blipFill>
+          <a:blip r:embed="rId3"/>
+          <a:stretch>
+            <a:fillRect/>
+          </a:stretch>
+        </p:blipFill>
+        <p:spPr>
+          <a:xfrm>
+            <a:off x="0" y="0"/>
+            <a:ext cx="12192000" cy="6858000"/>
+          </a:xfrm>
+          <a:prstGeom prst="rect">
+            <a:avLst/>
+          </a:prstGeom>
+        </p:spPr>
+      </p:pic>
+    </p:spTree>
+    <p:extLst>
+      <p:ext uri="{BB962C8B-B14F-4D97-AF65-F5344CB8AC3E}">
+        <p14:creationId xmlns:p14="http://schemas.microsoft.com/office/powerpoint/2010/main" val="380615654"/>
+      </p:ext>
+    </p:extLst>
+  </p:cSld>
+  <p:clrMapOvr>
+    <a:masterClrMapping/>
+  </p:clrMapOvr>
+</p:sld>
+</file>
+
+<file path=ppt/slides/slide6.xml><?xml version="1.0" encoding="utf-8"?>
+<p:sld xmlns:a="http://schemas.openxmlformats.org/drawingml/2006/main" xmlns:r="http://schemas.openxmlformats.org/officeDocument/2006/relationships" xmlns:p="http://schemas.openxmlformats.org/presentationml/2006/main">
+  <p:cSld>
+    <p:spTree>
+      <p:nvGrpSpPr>
+        <p:cNvPr id="1" name="">
+          <a:extLst>
+            <a:ext uri="{FF2B5EF4-FFF2-40B4-BE49-F238E27FC236}">
+              <a16:creationId xmlns:a16="http://schemas.microsoft.com/office/drawing/2014/main" id="{ECD85486-BE25-FEAB-F45B-EE60D4602E40}"/>
+            </a:ext>
+          </a:extLst>
+        </p:cNvPr>
+        <p:cNvGrpSpPr/>
+        <p:nvPr/>
+      </p:nvGrpSpPr>
+      <p:grpSpPr>
+        <a:xfrm>
+          <a:off x="0" y="0"/>
+          <a:ext cx="0" cy="0"/>
+          <a:chOff x="0" y="0"/>
+          <a:chExt cx="0" cy="0"/>
+        </a:xfrm>
+      </p:grpSpPr>
+      <p:sp>
+        <p:nvSpPr>
+          <p:cNvPr id="3" name="TextBox 2">
+            <a:extLst>
+              <a:ext uri="{FF2B5EF4-FFF2-40B4-BE49-F238E27FC236}">
+                <a16:creationId xmlns:a16="http://schemas.microsoft.com/office/drawing/2014/main" id="{B9C77E55-20D1-8D78-B71A-2753A1D2418D}"/>
+              </a:ext>
+            </a:extLst>
+          </p:cNvPr>
+          <p:cNvSpPr txBox="1"/>
+          <p:nvPr/>
+        </p:nvSpPr>
+        <p:spPr>
+          <a:xfrm>
+            <a:off x="1716505" y="876730"/>
+            <a:ext cx="8758990" cy="5104539"/>
+          </a:xfrm>
+          <a:prstGeom prst="rect">
+            <a:avLst/>
+          </a:prstGeom>
+          <a:noFill/>
+        </p:spPr>
+        <p:txBody>
+          <a:bodyPr wrap="square">
+            <a:spAutoFit/>
+          </a:bodyPr>
+          <a:lstStyle/>
+          <a:p>
+            <a:pPr algn="l">
+              <a:lnSpc>
+                <a:spcPct val="130000"/>
+              </a:lnSpc>
+              <a:buNone/>
+            </a:pPr>
+            <a:r>
+              <a:rPr lang="en-US" sz="1400" b="1" i="0" dirty="0">
+                <a:effectLst/>
+                <a:latin typeface="Arial" panose="020B0604020202020204" pitchFamily="34" charset="0"/>
+                <a:cs typeface="Arial" panose="020B0604020202020204" pitchFamily="34" charset="0"/>
+              </a:rPr>
+              <a:t>Context7</a:t>
+            </a:r>
+            <a:r>
+              <a:rPr lang="en-US" sz="1400" b="0" i="0" dirty="0">
+                <a:effectLst/>
+                <a:latin typeface="Arial" panose="020B0604020202020204" pitchFamily="34" charset="0"/>
+                <a:cs typeface="Arial" panose="020B0604020202020204" pitchFamily="34" charset="0"/>
+              </a:rPr>
+              <a:t> (made by </a:t>
+            </a:r>
+            <a:r>
+              <a:rPr lang="en-US" sz="1400" b="0" i="0" dirty="0" err="1">
+                <a:effectLst/>
+                <a:latin typeface="Arial" panose="020B0604020202020204" pitchFamily="34" charset="0"/>
+                <a:cs typeface="Arial" panose="020B0604020202020204" pitchFamily="34" charset="0"/>
+              </a:rPr>
+              <a:t>Upstash</a:t>
+            </a:r>
+            <a:r>
+              <a:rPr lang="en-US" sz="1400" b="0" i="0" dirty="0">
+                <a:effectLst/>
+                <a:latin typeface="Arial" panose="020B0604020202020204" pitchFamily="34" charset="0"/>
+                <a:cs typeface="Arial" panose="020B0604020202020204" pitchFamily="34" charset="0"/>
+              </a:rPr>
+              <a:t>)</a:t>
+            </a:r>
+          </a:p>
+          <a:p>
+            <a:pPr marL="233363" indent="-233363" algn="l">
+              <a:lnSpc>
+                <a:spcPct val="130000"/>
+              </a:lnSpc>
+              <a:buFont typeface="Arial" panose="020B0604020202020204" pitchFamily="34" charset="0"/>
+              <a:buChar char="•"/>
+            </a:pPr>
+            <a:r>
+              <a:rPr lang="en-US" sz="1400" b="0" i="0" dirty="0">
+                <a:effectLst/>
+                <a:latin typeface="Arial" panose="020B0604020202020204" pitchFamily="34" charset="0"/>
+                <a:cs typeface="Arial" panose="020B0604020202020204" pitchFamily="34" charset="0"/>
+              </a:rPr>
+              <a:t>Gives Claude current documentation for a specific version of a library, pulled straight from the source.</a:t>
+            </a:r>
+          </a:p>
+          <a:p>
+            <a:pPr marL="233363" indent="-233363" algn="l">
+              <a:lnSpc>
+                <a:spcPct val="130000"/>
+              </a:lnSpc>
+              <a:buFont typeface="Arial" panose="020B0604020202020204" pitchFamily="34" charset="0"/>
+              <a:buChar char="•"/>
+            </a:pPr>
+            <a:r>
+              <a:rPr lang="en-US" sz="1400" b="0" i="0" dirty="0">
+                <a:effectLst/>
+                <a:latin typeface="Arial" panose="020B0604020202020204" pitchFamily="34" charset="0"/>
+                <a:cs typeface="Arial" panose="020B0604020202020204" pitchFamily="34" charset="0"/>
+              </a:rPr>
+              <a:t>Prevents code that uses outdated or made-up APIs, such as React Router v7 versus react-router-dom.</a:t>
+            </a:r>
+          </a:p>
+          <a:p>
+            <a:pPr marL="233363" indent="-233363" algn="l">
+              <a:lnSpc>
+                <a:spcPct val="130000"/>
+              </a:lnSpc>
+              <a:buFont typeface="Arial" panose="020B0604020202020204" pitchFamily="34" charset="0"/>
+              <a:buChar char="•"/>
+            </a:pPr>
+            <a:r>
+              <a:rPr lang="en-US" sz="1400" b="0" i="0" dirty="0">
+                <a:effectLst/>
+                <a:latin typeface="Arial" panose="020B0604020202020204" pitchFamily="34" charset="0"/>
+                <a:cs typeface="Arial" panose="020B0604020202020204" pitchFamily="34" charset="0"/>
+              </a:rPr>
+              <a:t>It has two tools: one finds a library's ID and the other fetches that library's docs.</a:t>
+            </a:r>
+          </a:p>
+          <a:p>
+            <a:pPr marL="233363" indent="-233363" algn="l">
+              <a:lnSpc>
+                <a:spcPct val="130000"/>
+              </a:lnSpc>
+              <a:buFont typeface="Arial" panose="020B0604020202020204" pitchFamily="34" charset="0"/>
+              <a:buChar char="•"/>
+            </a:pPr>
+            <a:r>
+              <a:rPr lang="en-US" sz="1400" b="0" i="0" dirty="0">
+                <a:effectLst/>
+                <a:latin typeface="Arial" panose="020B0604020202020204" pitchFamily="34" charset="0"/>
+                <a:cs typeface="Arial" panose="020B0604020202020204" pitchFamily="34" charset="0"/>
+              </a:rPr>
+              <a:t>To use it, you usually add "use context7" to your prompt.</a:t>
+            </a:r>
+          </a:p>
+          <a:p>
+            <a:pPr algn="l">
+              <a:lnSpc>
+                <a:spcPct val="130000"/>
+              </a:lnSpc>
+              <a:buFont typeface="Arial" panose="020B0604020202020204" pitchFamily="34" charset="0"/>
+              <a:buChar char="•"/>
+            </a:pPr>
+            <a:endParaRPr lang="en-US" sz="1400" b="0" i="0" dirty="0">
+              <a:effectLst/>
+              <a:latin typeface="Arial" panose="020B0604020202020204" pitchFamily="34" charset="0"/>
+              <a:cs typeface="Arial" panose="020B0604020202020204" pitchFamily="34" charset="0"/>
+            </a:endParaRPr>
+          </a:p>
+          <a:p>
+            <a:pPr algn="l">
+              <a:lnSpc>
+                <a:spcPct val="130000"/>
+              </a:lnSpc>
+              <a:buNone/>
+            </a:pPr>
+            <a:r>
+              <a:rPr lang="en-US" sz="1400" b="1" i="0" dirty="0">
+                <a:effectLst/>
+                <a:latin typeface="Arial" panose="020B0604020202020204" pitchFamily="34" charset="0"/>
+                <a:cs typeface="Arial" panose="020B0604020202020204" pitchFamily="34" charset="0"/>
+              </a:rPr>
+              <a:t>Neon</a:t>
+            </a:r>
+            <a:r>
+              <a:rPr lang="en-US" sz="1400" b="0" i="0" dirty="0">
+                <a:effectLst/>
+                <a:latin typeface="Arial" panose="020B0604020202020204" pitchFamily="34" charset="0"/>
+                <a:cs typeface="Arial" panose="020B0604020202020204" pitchFamily="34" charset="0"/>
+              </a:rPr>
+              <a:t> (serverless Postgres)</a:t>
+            </a:r>
+          </a:p>
+          <a:p>
+            <a:pPr marL="233363" indent="-233363" algn="l">
+              <a:lnSpc>
+                <a:spcPct val="130000"/>
+              </a:lnSpc>
+              <a:buFont typeface="Arial" panose="020B0604020202020204" pitchFamily="34" charset="0"/>
+              <a:buChar char="•"/>
+            </a:pPr>
+            <a:r>
+              <a:rPr lang="en-US" sz="1400" b="0" i="0" dirty="0">
+                <a:effectLst/>
+                <a:latin typeface="Arial" panose="020B0604020202020204" pitchFamily="34" charset="0"/>
+                <a:cs typeface="Arial" panose="020B0604020202020204" pitchFamily="34" charset="0"/>
+              </a:rPr>
+              <a:t>Lets Claude manage your Neon Postgres projects, branches and databases through plain-language requests.</a:t>
+            </a:r>
+          </a:p>
+          <a:p>
+            <a:pPr marL="233363" indent="-233363" algn="l">
+              <a:lnSpc>
+                <a:spcPct val="130000"/>
+              </a:lnSpc>
+              <a:buFont typeface="Arial" panose="020B0604020202020204" pitchFamily="34" charset="0"/>
+              <a:buChar char="•"/>
+            </a:pPr>
+            <a:r>
+              <a:rPr lang="en-US" sz="1400" b="0" i="0" dirty="0">
+                <a:effectLst/>
+                <a:latin typeface="Arial" panose="020B0604020202020204" pitchFamily="34" charset="0"/>
+                <a:cs typeface="Arial" panose="020B0604020202020204" pitchFamily="34" charset="0"/>
+              </a:rPr>
+              <a:t>Claude can run SQL, inspect schemas and create or delete branches.</a:t>
+            </a:r>
+          </a:p>
+          <a:p>
+            <a:pPr marL="233363" indent="-233363" algn="l">
+              <a:lnSpc>
+                <a:spcPct val="130000"/>
+              </a:lnSpc>
+              <a:buFont typeface="Arial" panose="020B0604020202020204" pitchFamily="34" charset="0"/>
+              <a:buChar char="•"/>
+            </a:pPr>
+            <a:r>
+              <a:rPr lang="en-US" sz="1400" b="0" i="0" dirty="0">
+                <a:effectLst/>
+                <a:latin typeface="Arial" panose="020B0604020202020204" pitchFamily="34" charset="0"/>
+                <a:cs typeface="Arial" panose="020B0604020202020204" pitchFamily="34" charset="0"/>
+              </a:rPr>
+              <a:t>It can run a schema migration safely by testing it on a temporary branch before applying it to the main one.</a:t>
+            </a:r>
+          </a:p>
+          <a:p>
+            <a:pPr marL="233363" indent="-233363" algn="l">
+              <a:lnSpc>
+                <a:spcPct val="130000"/>
+              </a:lnSpc>
+              <a:buFont typeface="Arial" panose="020B0604020202020204" pitchFamily="34" charset="0"/>
+              <a:buChar char="•"/>
+            </a:pPr>
+            <a:r>
+              <a:rPr lang="en-US" sz="1400" b="0" i="0" dirty="0">
+                <a:effectLst/>
+                <a:latin typeface="Arial" panose="020B0604020202020204" pitchFamily="34" charset="0"/>
+                <a:cs typeface="Arial" panose="020B0604020202020204" pitchFamily="34" charset="0"/>
+              </a:rPr>
+              <a:t>It needs a Neon API key or an OAuth login.</a:t>
+            </a:r>
+          </a:p>
+          <a:p>
+            <a:pPr marL="233363" indent="-233363" algn="l">
+              <a:lnSpc>
+                <a:spcPct val="130000"/>
+              </a:lnSpc>
+              <a:buFont typeface="Arial" panose="020B0604020202020204" pitchFamily="34" charset="0"/>
+              <a:buChar char="•"/>
+            </a:pPr>
+            <a:endParaRPr lang="en-US" sz="1400" b="0" i="0" dirty="0">
+              <a:effectLst/>
+              <a:latin typeface="Arial" panose="020B0604020202020204" pitchFamily="34" charset="0"/>
+              <a:cs typeface="Arial" panose="020B0604020202020204" pitchFamily="34" charset="0"/>
+            </a:endParaRPr>
+          </a:p>
+          <a:p>
+            <a:pPr marL="233363" indent="-233363" algn="l">
+              <a:lnSpc>
+                <a:spcPct val="130000"/>
+              </a:lnSpc>
+              <a:buNone/>
+            </a:pPr>
+            <a:r>
+              <a:rPr lang="en-US" sz="1400" b="1" i="0" dirty="0">
+                <a:effectLst/>
+                <a:latin typeface="Arial" panose="020B0604020202020204" pitchFamily="34" charset="0"/>
+                <a:cs typeface="Arial" panose="020B0604020202020204" pitchFamily="34" charset="0"/>
+              </a:rPr>
+              <a:t>Playwright</a:t>
+            </a:r>
+            <a:r>
+              <a:rPr lang="en-US" sz="1400" b="0" i="0" dirty="0">
+                <a:effectLst/>
+                <a:latin typeface="Arial" panose="020B0604020202020204" pitchFamily="34" charset="0"/>
+                <a:cs typeface="Arial" panose="020B0604020202020204" pitchFamily="34" charset="0"/>
+              </a:rPr>
+              <a:t> (made by Microsoft)</a:t>
+            </a:r>
+          </a:p>
+          <a:p>
+            <a:pPr marL="233363" indent="-233363" algn="l">
+              <a:lnSpc>
+                <a:spcPct val="130000"/>
+              </a:lnSpc>
+              <a:buFont typeface="Arial" panose="020B0604020202020204" pitchFamily="34" charset="0"/>
+              <a:buChar char="•"/>
+            </a:pPr>
+            <a:r>
+              <a:rPr lang="en-US" sz="1400" b="0" i="0" dirty="0">
+                <a:effectLst/>
+                <a:latin typeface="Arial" panose="020B0604020202020204" pitchFamily="34" charset="0"/>
+                <a:cs typeface="Arial" panose="020B0604020202020204" pitchFamily="34" charset="0"/>
+              </a:rPr>
+              <a:t>Lets Claude drive a real browser: open pages, click, type, fill in forms and take screenshots.</a:t>
+            </a:r>
+          </a:p>
+          <a:p>
+            <a:pPr marL="233363" indent="-233363" algn="l">
+              <a:lnSpc>
+                <a:spcPct val="130000"/>
+              </a:lnSpc>
+              <a:buFont typeface="Arial" panose="020B0604020202020204" pitchFamily="34" charset="0"/>
+              <a:buChar char="•"/>
+            </a:pPr>
+            <a:r>
+              <a:rPr lang="en-US" sz="1400" b="0" i="0" dirty="0">
+                <a:effectLst/>
+                <a:latin typeface="Arial" panose="020B0604020202020204" pitchFamily="34" charset="0"/>
+                <a:cs typeface="Arial" panose="020B0604020202020204" pitchFamily="34" charset="0"/>
+              </a:rPr>
+              <a:t>It reads the page's accessibility tree rather than pixels, so it's fast and dependable.</a:t>
+            </a:r>
+          </a:p>
+          <a:p>
+            <a:pPr marL="233363" indent="-233363" algn="l">
+              <a:lnSpc>
+                <a:spcPct val="130000"/>
+              </a:lnSpc>
+              <a:buFont typeface="Arial" panose="020B0604020202020204" pitchFamily="34" charset="0"/>
+              <a:buChar char="•"/>
+            </a:pPr>
+            <a:r>
+              <a:rPr lang="en-US" sz="1400" b="0" i="0" dirty="0">
+                <a:effectLst/>
+                <a:latin typeface="Arial" panose="020B0604020202020204" pitchFamily="34" charset="0"/>
+                <a:cs typeface="Arial" panose="020B0604020202020204" pitchFamily="34" charset="0"/>
+              </a:rPr>
+              <a:t>It's useful for checking UI changes in the app you're running, like the favorites toggle in crypto-dash.</a:t>
+            </a:r>
+          </a:p>
+          <a:p>
+            <a:pPr marL="233363" indent="-233363" algn="l">
+              <a:lnSpc>
+                <a:spcPct val="130000"/>
+              </a:lnSpc>
+              <a:buFont typeface="Arial" panose="020B0604020202020204" pitchFamily="34" charset="0"/>
+              <a:buChar char="•"/>
+            </a:pPr>
+            <a:r>
+              <a:rPr lang="en-US" sz="1400" b="0" i="0" dirty="0">
+                <a:effectLst/>
+                <a:latin typeface="Arial" panose="020B0604020202020204" pitchFamily="34" charset="0"/>
+                <a:cs typeface="Arial" panose="020B0604020202020204" pitchFamily="34" charset="0"/>
+              </a:rPr>
+              <a:t>It's also used for scraping pages and writing end-to-end tests.</a:t>
+            </a:r>
+          </a:p>
+        </p:txBody>
+      </p:sp>
+    </p:spTree>
+    <p:extLst>
+      <p:ext uri="{BB962C8B-B14F-4D97-AF65-F5344CB8AC3E}">
+        <p14:creationId xmlns:p14="http://schemas.microsoft.com/office/powerpoint/2010/main" val="1447866230"/>
+      </p:ext>
+    </p:extLst>
+  </p:cSld>
+  <p:clrMapOvr>
+    <a:masterClrMapping/>
+  </p:clrMapOvr>
+</p:sld>
+</file>
+
+<file path=ppt/slides/slide7.xml><?xml version="1.0" encoding="utf-8"?>
+<p:sld xmlns:a="http://schemas.openxmlformats.org/drawingml/2006/main" xmlns:r="http://schemas.openxmlformats.org/officeDocument/2006/relationships" xmlns:p="http://schemas.openxmlformats.org/presentationml/2006/main">
+  <p:cSld>
+    <p:spTree>
+      <p:nvGrpSpPr>
+        <p:cNvPr id="1" name="">
+          <a:extLst>
+            <a:ext uri="{FF2B5EF4-FFF2-40B4-BE49-F238E27FC236}">
+              <a16:creationId xmlns:a16="http://schemas.microsoft.com/office/drawing/2014/main" id="{9C3EADCD-D817-9C4F-79F1-67FAF1FB9D68}"/>
+            </a:ext>
+          </a:extLst>
+        </p:cNvPr>
+        <p:cNvGrpSpPr/>
+        <p:nvPr/>
+      </p:nvGrpSpPr>
+      <p:grpSpPr>
+        <a:xfrm>
+          <a:off x="0" y="0"/>
+          <a:ext cx="0" cy="0"/>
+          <a:chOff x="0" y="0"/>
+          <a:chExt cx="0" cy="0"/>
+        </a:xfrm>
+      </p:grpSpPr>
+      <p:pic>
+        <p:nvPicPr>
+          <p:cNvPr id="3" name="Picture 2">
+            <a:extLst>
+              <a:ext uri="{FF2B5EF4-FFF2-40B4-BE49-F238E27FC236}">
+                <a16:creationId xmlns:a16="http://schemas.microsoft.com/office/drawing/2014/main" id="{F72441C2-0310-5507-6C5A-EFB01907C5F6}"/>
+              </a:ext>
+            </a:extLst>
+          </p:cNvPr>
+          <p:cNvPicPr>
+            <a:picLocks noChangeAspect="1"/>
+          </p:cNvPicPr>
+          <p:nvPr/>
+        </p:nvPicPr>
+        <p:blipFill>
+          <a:blip r:embed="rId3"/>
+          <a:stretch>
+            <a:fillRect/>
+          </a:stretch>
+        </p:blipFill>
+        <p:spPr>
+          <a:xfrm>
+            <a:off x="0" y="0"/>
+            <a:ext cx="12192000" cy="6858000"/>
+          </a:xfrm>
+          <a:prstGeom prst="rect">
+            <a:avLst/>
+          </a:prstGeom>
+        </p:spPr>
+      </p:pic>
+    </p:spTree>
+    <p:extLst>
+      <p:ext uri="{BB962C8B-B14F-4D97-AF65-F5344CB8AC3E}">
+        <p14:creationId xmlns:p14="http://schemas.microsoft.com/office/powerpoint/2010/main" val="1412681340"/>
+      </p:ext>
+    </p:extLst>
+  </p:cSld>
+  <p:clrMapOvr>
+    <a:masterClrMapping/>
+  </p:clrMapOvr>
+</p:sld>
+</file>
+
+<file path=ppt/slides/slide8.xml><?xml version="1.0" encoding="utf-8"?>
+<p:sld xmlns:a="http://schemas.openxmlformats.org/drawingml/2006/main" xmlns:r="http://schemas.openxmlformats.org/officeDocument/2006/relationships" xmlns:p="http://schemas.openxmlformats.org/presentationml/2006/main">
+  <p:cSld>
+    <p:spTree>
+      <p:nvGrpSpPr>
+        <p:cNvPr id="1" name="">
+          <a:extLst>
+            <a:ext uri="{FF2B5EF4-FFF2-40B4-BE49-F238E27FC236}">
+              <a16:creationId xmlns:a16="http://schemas.microsoft.com/office/drawing/2014/main" id="{CB081C4E-45EC-EA94-54F5-220DDE47C201}"/>
+            </a:ext>
+          </a:extLst>
+        </p:cNvPr>
+        <p:cNvGrpSpPr/>
+        <p:nvPr/>
+      </p:nvGrpSpPr>
+      <p:grpSpPr>
+        <a:xfrm>
+          <a:off x="0" y="0"/>
+          <a:ext cx="0" cy="0"/>
+          <a:chOff x="0" y="0"/>
+          <a:chExt cx="0" cy="0"/>
+        </a:xfrm>
+      </p:grpSpPr>
+    </p:spTree>
+    <p:extLst>
+      <p:ext uri="{BB962C8B-B14F-4D97-AF65-F5344CB8AC3E}">
+        <p14:creationId xmlns:p14="http://schemas.microsoft.com/office/powerpoint/2010/main" val="1464567321"/>
       </p:ext>
     </p:extLst>
   </p:cSld>

</xml_diff>